<commit_message>
Update slide decks (Ch1-Ch7, Wk1 L3-L4, Wk2, Wk3) with page numbers
Co-Authored-By: Claude Opus 4.8 (1M context) <noreply@anthropic.com>
</commit_message>
<xml_diff>
--- a/files/week2/english/Wk2_L7_slides.pptx
+++ b/files/week2/english/Wk2_L7_slides.pptx
@@ -266,7 +266,7 @@
           <a:p>
             <a:fld id="{A34E029D-4975-9049-A4B2-065531108780}" type="datetimeFigureOut">
               <a:rPr lang="en-US" smtClean="0"/>
-              <a:t>7/14/2026</a:t>
+              <a:t>7/18/2026</a:t>
             </a:fld>
             <a:endParaRPr lang="en-US"/>
           </a:p>
@@ -3732,7 +3732,7 @@
           <a:p>
             <a:fld id="{66FF1AA2-E424-AF48-BE0B-AA2CA13DBDC8}" type="datetimeFigureOut">
               <a:rPr lang="en-US" smtClean="0"/>
-              <a:t>7/14/2026</a:t>
+              <a:t>7/18/2026</a:t>
             </a:fld>
             <a:endParaRPr lang="en-US"/>
           </a:p>
@@ -4142,6 +4142,54 @@
           </a:p>
         </p:txBody>
       </p:sp>
+      <p:sp>
+        <p:nvSpPr>
+          <p:cNvPr id="3" name="AutoPageNum">
+            <a:extLst>
+              <a:ext uri="{FF2B5EF4-FFF2-40B4-BE49-F238E27FC236}">
+                <a16:creationId xmlns:a16="http://schemas.microsoft.com/office/drawing/2014/main" id="{F6D82D39-4083-4EA1-971C-D07C31FFBB0D}"/>
+              </a:ext>
+            </a:extLst>
+          </p:cNvPr>
+          <p:cNvSpPr txBox="1"/>
+          <p:nvPr/>
+        </p:nvSpPr>
+        <p:spPr>
+          <a:xfrm>
+            <a:off x="11633200" y="6451600"/>
+            <a:ext cx="508000" cy="304800"/>
+          </a:xfrm>
+          <a:prstGeom prst="rect">
+            <a:avLst/>
+          </a:prstGeom>
+          <a:noFill/>
+        </p:spPr>
+        <p:txBody>
+          <a:bodyPr vert="horz" wrap="square" lIns="0" tIns="0" rIns="0" bIns="0" rtlCol="0">
+            <a:noAutofit/>
+          </a:bodyPr>
+          <a:lstStyle/>
+          <a:p>
+            <a:pPr algn="ctr"/>
+            <a:fld id="{765E9695-8AA2-40FC-8EDF-E08360AB4411}" type="slidenum">
+              <a:rPr lang="en-US" sz="1400" smtClean="0">
+                <a:solidFill>
+                  <a:srgbClr val="FFFFFF"/>
+                </a:solidFill>
+                <a:latin typeface="Arial" panose="020B0604020202020204" pitchFamily="34" charset="0"/>
+              </a:rPr>
+              <a:pPr algn="ctr"/>
+              <a:t>1</a:t>
+            </a:fld>
+            <a:endParaRPr lang="en-US" sz="1400">
+              <a:solidFill>
+                <a:srgbClr val="FFFFFF"/>
+              </a:solidFill>
+              <a:latin typeface="Arial" panose="020B0604020202020204" pitchFamily="34" charset="0"/>
+            </a:endParaRPr>
+          </a:p>
+        </p:txBody>
+      </p:sp>
     </p:spTree>
     <p:extLst>
       <p:ext uri="{BB962C8B-B14F-4D97-AF65-F5344CB8AC3E}">
@@ -4210,6 +4258,54 @@
               <a:rPr lang="en-US" dirty="0"/>
               <a:t>Revenue Recognition - Cases</a:t>
             </a:r>
+          </a:p>
+        </p:txBody>
+      </p:sp>
+      <p:sp>
+        <p:nvSpPr>
+          <p:cNvPr id="3" name="AutoPageNum">
+            <a:extLst>
+              <a:ext uri="{FF2B5EF4-FFF2-40B4-BE49-F238E27FC236}">
+                <a16:creationId xmlns:a16="http://schemas.microsoft.com/office/drawing/2014/main" id="{23BCB14D-9FA0-B473-6D19-F86E21E98257}"/>
+              </a:ext>
+            </a:extLst>
+          </p:cNvPr>
+          <p:cNvSpPr txBox="1"/>
+          <p:nvPr/>
+        </p:nvSpPr>
+        <p:spPr>
+          <a:xfrm>
+            <a:off x="11633200" y="6451600"/>
+            <a:ext cx="508000" cy="304800"/>
+          </a:xfrm>
+          <a:prstGeom prst="rect">
+            <a:avLst/>
+          </a:prstGeom>
+          <a:noFill/>
+        </p:spPr>
+        <p:txBody>
+          <a:bodyPr vert="horz" wrap="square" lIns="0" tIns="0" rIns="0" bIns="0" rtlCol="0">
+            <a:noAutofit/>
+          </a:bodyPr>
+          <a:lstStyle/>
+          <a:p>
+            <a:pPr algn="ctr"/>
+            <a:fld id="{8AF55267-CD75-49EB-AAC6-4B83F2D1318E}" type="slidenum">
+              <a:rPr lang="en-US" sz="1400" smtClean="0">
+                <a:solidFill>
+                  <a:srgbClr val="000000"/>
+                </a:solidFill>
+                <a:latin typeface="Arial" panose="020B0604020202020204" pitchFamily="34" charset="0"/>
+              </a:rPr>
+              <a:pPr algn="ctr"/>
+              <a:t>10</a:t>
+            </a:fld>
+            <a:endParaRPr lang="en-US" sz="1400">
+              <a:solidFill>
+                <a:srgbClr val="000000"/>
+              </a:solidFill>
+              <a:latin typeface="Arial" panose="020B0604020202020204" pitchFamily="34" charset="0"/>
+            </a:endParaRPr>
           </a:p>
         </p:txBody>
       </p:sp>
@@ -5428,6 +5524,54 @@
           </a:p>
         </p:txBody>
       </p:sp>
+      <p:sp>
+        <p:nvSpPr>
+          <p:cNvPr id="4" name="AutoPageNum">
+            <a:extLst>
+              <a:ext uri="{FF2B5EF4-FFF2-40B4-BE49-F238E27FC236}">
+                <a16:creationId xmlns:a16="http://schemas.microsoft.com/office/drawing/2014/main" id="{C7836EC3-C7B2-4CAE-4E6D-9E748043BDBA}"/>
+              </a:ext>
+            </a:extLst>
+          </p:cNvPr>
+          <p:cNvSpPr txBox="1"/>
+          <p:nvPr/>
+        </p:nvSpPr>
+        <p:spPr>
+          <a:xfrm>
+            <a:off x="11633200" y="6451600"/>
+            <a:ext cx="508000" cy="304800"/>
+          </a:xfrm>
+          <a:prstGeom prst="rect">
+            <a:avLst/>
+          </a:prstGeom>
+          <a:noFill/>
+        </p:spPr>
+        <p:txBody>
+          <a:bodyPr vert="horz" wrap="square" lIns="0" tIns="0" rIns="0" bIns="0" rtlCol="0">
+            <a:noAutofit/>
+          </a:bodyPr>
+          <a:lstStyle/>
+          <a:p>
+            <a:pPr algn="ctr"/>
+            <a:fld id="{B886B00D-E6E3-4507-8A16-128FB53F1E5F}" type="slidenum">
+              <a:rPr lang="en-US" sz="1400" smtClean="0">
+                <a:solidFill>
+                  <a:srgbClr val="FFFFFF"/>
+                </a:solidFill>
+                <a:latin typeface="Arial" panose="020B0604020202020204" pitchFamily="34" charset="0"/>
+              </a:rPr>
+              <a:pPr algn="ctr"/>
+              <a:t>11</a:t>
+            </a:fld>
+            <a:endParaRPr lang="en-US" sz="1400">
+              <a:solidFill>
+                <a:srgbClr val="FFFFFF"/>
+              </a:solidFill>
+              <a:latin typeface="Arial" panose="020B0604020202020204" pitchFamily="34" charset="0"/>
+            </a:endParaRPr>
+          </a:p>
+        </p:txBody>
+      </p:sp>
     </p:spTree>
     <p:extLst>
       <p:ext uri="{BB962C8B-B14F-4D97-AF65-F5344CB8AC3E}">
@@ -6568,6 +6712,54 @@
           </a:p>
         </p:txBody>
       </p:sp>
+      <p:sp>
+        <p:nvSpPr>
+          <p:cNvPr id="6" name="AutoPageNum">
+            <a:extLst>
+              <a:ext uri="{FF2B5EF4-FFF2-40B4-BE49-F238E27FC236}">
+                <a16:creationId xmlns:a16="http://schemas.microsoft.com/office/drawing/2014/main" id="{65ED9FA1-F236-0016-5498-BF985DEB9ABF}"/>
+              </a:ext>
+            </a:extLst>
+          </p:cNvPr>
+          <p:cNvSpPr txBox="1"/>
+          <p:nvPr/>
+        </p:nvSpPr>
+        <p:spPr>
+          <a:xfrm>
+            <a:off x="11633200" y="6451600"/>
+            <a:ext cx="508000" cy="304800"/>
+          </a:xfrm>
+          <a:prstGeom prst="rect">
+            <a:avLst/>
+          </a:prstGeom>
+          <a:noFill/>
+        </p:spPr>
+        <p:txBody>
+          <a:bodyPr vert="horz" wrap="square" lIns="0" tIns="0" rIns="0" bIns="0" rtlCol="0">
+            <a:noAutofit/>
+          </a:bodyPr>
+          <a:lstStyle/>
+          <a:p>
+            <a:pPr algn="ctr"/>
+            <a:fld id="{BFC10A5C-710A-4AB1-89EA-D6FE2762895B}" type="slidenum">
+              <a:rPr lang="en-US" sz="1400" smtClean="0">
+                <a:solidFill>
+                  <a:srgbClr val="FFFFFF"/>
+                </a:solidFill>
+                <a:latin typeface="Arial" panose="020B0604020202020204" pitchFamily="34" charset="0"/>
+              </a:rPr>
+              <a:pPr algn="ctr"/>
+              <a:t>12</a:t>
+            </a:fld>
+            <a:endParaRPr lang="en-US" sz="1400">
+              <a:solidFill>
+                <a:srgbClr val="FFFFFF"/>
+              </a:solidFill>
+              <a:latin typeface="Arial" panose="020B0604020202020204" pitchFamily="34" charset="0"/>
+            </a:endParaRPr>
+          </a:p>
+        </p:txBody>
+      </p:sp>
     </p:spTree>
     <p:extLst>
       <p:ext uri="{BB962C8B-B14F-4D97-AF65-F5344CB8AC3E}">
@@ -7762,6 +7954,54 @@
           </a:p>
         </p:txBody>
       </p:sp>
+      <p:sp>
+        <p:nvSpPr>
+          <p:cNvPr id="11" name="AutoPageNum">
+            <a:extLst>
+              <a:ext uri="{FF2B5EF4-FFF2-40B4-BE49-F238E27FC236}">
+                <a16:creationId xmlns:a16="http://schemas.microsoft.com/office/drawing/2014/main" id="{32B55C24-3D07-9225-CB1D-3492B41323A6}"/>
+              </a:ext>
+            </a:extLst>
+          </p:cNvPr>
+          <p:cNvSpPr txBox="1"/>
+          <p:nvPr/>
+        </p:nvSpPr>
+        <p:spPr>
+          <a:xfrm>
+            <a:off x="11633200" y="6451600"/>
+            <a:ext cx="508000" cy="304800"/>
+          </a:xfrm>
+          <a:prstGeom prst="rect">
+            <a:avLst/>
+          </a:prstGeom>
+          <a:noFill/>
+        </p:spPr>
+        <p:txBody>
+          <a:bodyPr vert="horz" wrap="square" lIns="0" tIns="0" rIns="0" bIns="0" rtlCol="0">
+            <a:noAutofit/>
+          </a:bodyPr>
+          <a:lstStyle/>
+          <a:p>
+            <a:pPr algn="ctr"/>
+            <a:fld id="{1E74C8B8-EA64-4F54-9709-E55F98166753}" type="slidenum">
+              <a:rPr lang="en-US" sz="1400" smtClean="0">
+                <a:solidFill>
+                  <a:srgbClr val="FFFFFF"/>
+                </a:solidFill>
+                <a:latin typeface="Arial" panose="020B0604020202020204" pitchFamily="34" charset="0"/>
+              </a:rPr>
+              <a:pPr algn="ctr"/>
+              <a:t>13</a:t>
+            </a:fld>
+            <a:endParaRPr lang="en-US" sz="1400">
+              <a:solidFill>
+                <a:srgbClr val="FFFFFF"/>
+              </a:solidFill>
+              <a:latin typeface="Arial" panose="020B0604020202020204" pitchFamily="34" charset="0"/>
+            </a:endParaRPr>
+          </a:p>
+        </p:txBody>
+      </p:sp>
     </p:spTree>
     <p:extLst>
       <p:ext uri="{BB962C8B-B14F-4D97-AF65-F5344CB8AC3E}">
@@ -8861,6 +9101,54 @@
           </a:p>
         </p:txBody>
       </p:sp>
+      <p:sp>
+        <p:nvSpPr>
+          <p:cNvPr id="11" name="AutoPageNum">
+            <a:extLst>
+              <a:ext uri="{FF2B5EF4-FFF2-40B4-BE49-F238E27FC236}">
+                <a16:creationId xmlns:a16="http://schemas.microsoft.com/office/drawing/2014/main" id="{6BB41DD6-209E-8E38-AC97-7EEE828B82C2}"/>
+              </a:ext>
+            </a:extLst>
+          </p:cNvPr>
+          <p:cNvSpPr txBox="1"/>
+          <p:nvPr/>
+        </p:nvSpPr>
+        <p:spPr>
+          <a:xfrm>
+            <a:off x="11633200" y="6451600"/>
+            <a:ext cx="508000" cy="304800"/>
+          </a:xfrm>
+          <a:prstGeom prst="rect">
+            <a:avLst/>
+          </a:prstGeom>
+          <a:noFill/>
+        </p:spPr>
+        <p:txBody>
+          <a:bodyPr vert="horz" wrap="square" lIns="0" tIns="0" rIns="0" bIns="0" rtlCol="0">
+            <a:noAutofit/>
+          </a:bodyPr>
+          <a:lstStyle/>
+          <a:p>
+            <a:pPr algn="ctr"/>
+            <a:fld id="{EF1911F1-43C3-46AB-9C2A-6D919E2D6B5D}" type="slidenum">
+              <a:rPr lang="en-US" sz="1400" smtClean="0">
+                <a:solidFill>
+                  <a:srgbClr val="FFFFFF"/>
+                </a:solidFill>
+                <a:latin typeface="Arial" panose="020B0604020202020204" pitchFamily="34" charset="0"/>
+              </a:rPr>
+              <a:pPr algn="ctr"/>
+              <a:t>14</a:t>
+            </a:fld>
+            <a:endParaRPr lang="en-US" sz="1400">
+              <a:solidFill>
+                <a:srgbClr val="FFFFFF"/>
+              </a:solidFill>
+              <a:latin typeface="Arial" panose="020B0604020202020204" pitchFamily="34" charset="0"/>
+            </a:endParaRPr>
+          </a:p>
+        </p:txBody>
+      </p:sp>
     </p:spTree>
     <p:extLst>
       <p:ext uri="{BB962C8B-B14F-4D97-AF65-F5344CB8AC3E}">
@@ -10075,6 +10363,54 @@
           </a:p>
         </p:txBody>
       </p:sp>
+      <p:sp>
+        <p:nvSpPr>
+          <p:cNvPr id="11" name="AutoPageNum">
+            <a:extLst>
+              <a:ext uri="{FF2B5EF4-FFF2-40B4-BE49-F238E27FC236}">
+                <a16:creationId xmlns:a16="http://schemas.microsoft.com/office/drawing/2014/main" id="{11E5EE78-D2E5-A017-65E3-98DB78317686}"/>
+              </a:ext>
+            </a:extLst>
+          </p:cNvPr>
+          <p:cNvSpPr txBox="1"/>
+          <p:nvPr/>
+        </p:nvSpPr>
+        <p:spPr>
+          <a:xfrm>
+            <a:off x="11633200" y="6451600"/>
+            <a:ext cx="508000" cy="304800"/>
+          </a:xfrm>
+          <a:prstGeom prst="rect">
+            <a:avLst/>
+          </a:prstGeom>
+          <a:noFill/>
+        </p:spPr>
+        <p:txBody>
+          <a:bodyPr vert="horz" wrap="square" lIns="0" tIns="0" rIns="0" bIns="0" rtlCol="0">
+            <a:noAutofit/>
+          </a:bodyPr>
+          <a:lstStyle/>
+          <a:p>
+            <a:pPr algn="ctr"/>
+            <a:fld id="{DB146FC2-17A3-48E0-8037-894FBA76C5B2}" type="slidenum">
+              <a:rPr lang="en-US" sz="1400" smtClean="0">
+                <a:solidFill>
+                  <a:srgbClr val="FFFFFF"/>
+                </a:solidFill>
+                <a:latin typeface="Arial" panose="020B0604020202020204" pitchFamily="34" charset="0"/>
+              </a:rPr>
+              <a:pPr algn="ctr"/>
+              <a:t>15</a:t>
+            </a:fld>
+            <a:endParaRPr lang="en-US" sz="1400">
+              <a:solidFill>
+                <a:srgbClr val="FFFFFF"/>
+              </a:solidFill>
+              <a:latin typeface="Arial" panose="020B0604020202020204" pitchFamily="34" charset="0"/>
+            </a:endParaRPr>
+          </a:p>
+        </p:txBody>
+      </p:sp>
     </p:spTree>
     <p:extLst>
       <p:ext uri="{BB962C8B-B14F-4D97-AF65-F5344CB8AC3E}">
@@ -10146,6 +10482,54 @@
           </a:p>
         </p:txBody>
       </p:sp>
+      <p:sp>
+        <p:nvSpPr>
+          <p:cNvPr id="3" name="AutoPageNum">
+            <a:extLst>
+              <a:ext uri="{FF2B5EF4-FFF2-40B4-BE49-F238E27FC236}">
+                <a16:creationId xmlns:a16="http://schemas.microsoft.com/office/drawing/2014/main" id="{8957E387-5CC7-3F8A-D80F-0AA865B255B2}"/>
+              </a:ext>
+            </a:extLst>
+          </p:cNvPr>
+          <p:cNvSpPr txBox="1"/>
+          <p:nvPr/>
+        </p:nvSpPr>
+        <p:spPr>
+          <a:xfrm>
+            <a:off x="11633200" y="6451600"/>
+            <a:ext cx="508000" cy="304800"/>
+          </a:xfrm>
+          <a:prstGeom prst="rect">
+            <a:avLst/>
+          </a:prstGeom>
+          <a:noFill/>
+        </p:spPr>
+        <p:txBody>
+          <a:bodyPr vert="horz" wrap="square" lIns="0" tIns="0" rIns="0" bIns="0" rtlCol="0">
+            <a:noAutofit/>
+          </a:bodyPr>
+          <a:lstStyle/>
+          <a:p>
+            <a:pPr algn="ctr"/>
+            <a:fld id="{750DDEE2-3D09-419B-AC09-192EC1ECC224}" type="slidenum">
+              <a:rPr lang="en-US" sz="1400" smtClean="0">
+                <a:solidFill>
+                  <a:srgbClr val="000000"/>
+                </a:solidFill>
+                <a:latin typeface="Arial" panose="020B0604020202020204" pitchFamily="34" charset="0"/>
+              </a:rPr>
+              <a:pPr algn="ctr"/>
+              <a:t>16</a:t>
+            </a:fld>
+            <a:endParaRPr lang="en-US" sz="1400">
+              <a:solidFill>
+                <a:srgbClr val="000000"/>
+              </a:solidFill>
+              <a:latin typeface="Arial" panose="020B0604020202020204" pitchFamily="34" charset="0"/>
+            </a:endParaRPr>
+          </a:p>
+        </p:txBody>
+      </p:sp>
     </p:spTree>
     <p:extLst>
       <p:ext uri="{BB962C8B-B14F-4D97-AF65-F5344CB8AC3E}">
@@ -10749,6 +11133,54 @@
           </a:fontRef>
         </p:style>
       </p:cxnSp>
+      <p:sp>
+        <p:nvSpPr>
+          <p:cNvPr id="4" name="AutoPageNum">
+            <a:extLst>
+              <a:ext uri="{FF2B5EF4-FFF2-40B4-BE49-F238E27FC236}">
+                <a16:creationId xmlns:a16="http://schemas.microsoft.com/office/drawing/2014/main" id="{05D2FE4A-8920-6B3D-C45A-73DBD5EFBD12}"/>
+              </a:ext>
+            </a:extLst>
+          </p:cNvPr>
+          <p:cNvSpPr txBox="1"/>
+          <p:nvPr/>
+        </p:nvSpPr>
+        <p:spPr>
+          <a:xfrm>
+            <a:off x="11633200" y="6451600"/>
+            <a:ext cx="508000" cy="304800"/>
+          </a:xfrm>
+          <a:prstGeom prst="rect">
+            <a:avLst/>
+          </a:prstGeom>
+          <a:noFill/>
+        </p:spPr>
+        <p:txBody>
+          <a:bodyPr vert="horz" wrap="square" lIns="0" tIns="0" rIns="0" bIns="0" rtlCol="0">
+            <a:noAutofit/>
+          </a:bodyPr>
+          <a:lstStyle/>
+          <a:p>
+            <a:pPr algn="ctr"/>
+            <a:fld id="{8061B315-6880-4C9D-AC19-CEDBC7F927CD}" type="slidenum">
+              <a:rPr lang="en-US" sz="1400" smtClean="0">
+                <a:solidFill>
+                  <a:srgbClr val="FFFFFF"/>
+                </a:solidFill>
+                <a:latin typeface="Arial" panose="020B0604020202020204" pitchFamily="34" charset="0"/>
+              </a:rPr>
+              <a:pPr algn="ctr"/>
+              <a:t>17</a:t>
+            </a:fld>
+            <a:endParaRPr lang="en-US" sz="1400">
+              <a:solidFill>
+                <a:srgbClr val="FFFFFF"/>
+              </a:solidFill>
+              <a:latin typeface="Arial" panose="020B0604020202020204" pitchFamily="34" charset="0"/>
+            </a:endParaRPr>
+          </a:p>
+        </p:txBody>
+      </p:sp>
     </p:spTree>
     <p:extLst>
       <p:ext uri="{BB962C8B-B14F-4D97-AF65-F5344CB8AC3E}">
@@ -11354,6 +11786,54 @@
               </a:tabLst>
             </a:pPr>
             <a:endParaRPr lang="en-US" sz="2000" dirty="0"/>
+          </a:p>
+        </p:txBody>
+      </p:sp>
+      <p:sp>
+        <p:nvSpPr>
+          <p:cNvPr id="4" name="AutoPageNum">
+            <a:extLst>
+              <a:ext uri="{FF2B5EF4-FFF2-40B4-BE49-F238E27FC236}">
+                <a16:creationId xmlns:a16="http://schemas.microsoft.com/office/drawing/2014/main" id="{66F1BFB4-CFD9-7665-642F-978123CCC3BB}"/>
+              </a:ext>
+            </a:extLst>
+          </p:cNvPr>
+          <p:cNvSpPr txBox="1"/>
+          <p:nvPr/>
+        </p:nvSpPr>
+        <p:spPr>
+          <a:xfrm>
+            <a:off x="11633200" y="6451600"/>
+            <a:ext cx="508000" cy="304800"/>
+          </a:xfrm>
+          <a:prstGeom prst="rect">
+            <a:avLst/>
+          </a:prstGeom>
+          <a:noFill/>
+        </p:spPr>
+        <p:txBody>
+          <a:bodyPr vert="horz" wrap="square" lIns="0" tIns="0" rIns="0" bIns="0" rtlCol="0">
+            <a:noAutofit/>
+          </a:bodyPr>
+          <a:lstStyle/>
+          <a:p>
+            <a:pPr algn="ctr"/>
+            <a:fld id="{0FD9E4DE-6E80-4B8C-A029-F6FA886EFA4F}" type="slidenum">
+              <a:rPr lang="en-US" sz="1400" smtClean="0">
+                <a:solidFill>
+                  <a:srgbClr val="FFFFFF"/>
+                </a:solidFill>
+                <a:latin typeface="Arial" panose="020B0604020202020204" pitchFamily="34" charset="0"/>
+              </a:rPr>
+              <a:pPr algn="ctr"/>
+              <a:t>18</a:t>
+            </a:fld>
+            <a:endParaRPr lang="en-US" sz="1400">
+              <a:solidFill>
+                <a:srgbClr val="FFFFFF"/>
+              </a:solidFill>
+              <a:latin typeface="Arial" panose="020B0604020202020204" pitchFamily="34" charset="0"/>
+            </a:endParaRPr>
           </a:p>
         </p:txBody>
       </p:sp>
@@ -13024,6 +13504,54 @@
           </a:graphicData>
         </a:graphic>
       </p:graphicFrame>
+      <p:sp>
+        <p:nvSpPr>
+          <p:cNvPr id="8" name="AutoPageNum">
+            <a:extLst>
+              <a:ext uri="{FF2B5EF4-FFF2-40B4-BE49-F238E27FC236}">
+                <a16:creationId xmlns:a16="http://schemas.microsoft.com/office/drawing/2014/main" id="{1E03341E-6DD3-62E0-2E20-8633168193B9}"/>
+              </a:ext>
+            </a:extLst>
+          </p:cNvPr>
+          <p:cNvSpPr txBox="1"/>
+          <p:nvPr/>
+        </p:nvSpPr>
+        <p:spPr>
+          <a:xfrm>
+            <a:off x="11633200" y="6451600"/>
+            <a:ext cx="508000" cy="304800"/>
+          </a:xfrm>
+          <a:prstGeom prst="rect">
+            <a:avLst/>
+          </a:prstGeom>
+          <a:noFill/>
+        </p:spPr>
+        <p:txBody>
+          <a:bodyPr vert="horz" wrap="square" lIns="0" tIns="0" rIns="0" bIns="0" rtlCol="0">
+            <a:noAutofit/>
+          </a:bodyPr>
+          <a:lstStyle/>
+          <a:p>
+            <a:pPr algn="ctr"/>
+            <a:fld id="{6EA45E26-0B3C-4709-BA40-AEFC9D7865DE}" type="slidenum">
+              <a:rPr lang="en-US" sz="1400" smtClean="0">
+                <a:solidFill>
+                  <a:srgbClr val="FFFFFF"/>
+                </a:solidFill>
+                <a:latin typeface="Arial" panose="020B0604020202020204" pitchFamily="34" charset="0"/>
+              </a:rPr>
+              <a:pPr algn="ctr"/>
+              <a:t>19</a:t>
+            </a:fld>
+            <a:endParaRPr lang="en-US" sz="1400">
+              <a:solidFill>
+                <a:srgbClr val="FFFFFF"/>
+              </a:solidFill>
+              <a:latin typeface="Arial" panose="020B0604020202020204" pitchFamily="34" charset="0"/>
+            </a:endParaRPr>
+          </a:p>
+        </p:txBody>
+      </p:sp>
     </p:spTree>
     <p:extLst>
       <p:ext uri="{BB962C8B-B14F-4D97-AF65-F5344CB8AC3E}">
@@ -14012,6 +14540,54 @@
               <a:t>Cost Recovery</a:t>
             </a:r>
             <a:endParaRPr lang="en-US" dirty="0"/>
+          </a:p>
+        </p:txBody>
+      </p:sp>
+      <p:sp>
+        <p:nvSpPr>
+          <p:cNvPr id="4" name="AutoPageNum">
+            <a:extLst>
+              <a:ext uri="{FF2B5EF4-FFF2-40B4-BE49-F238E27FC236}">
+                <a16:creationId xmlns:a16="http://schemas.microsoft.com/office/drawing/2014/main" id="{64AD72CC-B2EC-35FE-641B-DA0B4B4BD9E9}"/>
+              </a:ext>
+            </a:extLst>
+          </p:cNvPr>
+          <p:cNvSpPr txBox="1"/>
+          <p:nvPr/>
+        </p:nvSpPr>
+        <p:spPr>
+          <a:xfrm>
+            <a:off x="11633200" y="6451600"/>
+            <a:ext cx="508000" cy="304800"/>
+          </a:xfrm>
+          <a:prstGeom prst="rect">
+            <a:avLst/>
+          </a:prstGeom>
+          <a:noFill/>
+        </p:spPr>
+        <p:txBody>
+          <a:bodyPr vert="horz" wrap="square" lIns="0" tIns="0" rIns="0" bIns="0" rtlCol="0">
+            <a:noAutofit/>
+          </a:bodyPr>
+          <a:lstStyle/>
+          <a:p>
+            <a:pPr algn="ctr"/>
+            <a:fld id="{46414C54-82F5-406D-A86B-4398E16B48FE}" type="slidenum">
+              <a:rPr lang="en-US" sz="1400" smtClean="0">
+                <a:solidFill>
+                  <a:srgbClr val="FFFFFF"/>
+                </a:solidFill>
+                <a:latin typeface="Arial" panose="020B0604020202020204" pitchFamily="34" charset="0"/>
+              </a:rPr>
+              <a:pPr algn="ctr"/>
+              <a:t>2</a:t>
+            </a:fld>
+            <a:endParaRPr lang="en-US" sz="1400">
+              <a:solidFill>
+                <a:srgbClr val="FFFFFF"/>
+              </a:solidFill>
+              <a:latin typeface="Arial" panose="020B0604020202020204" pitchFamily="34" charset="0"/>
+            </a:endParaRPr>
           </a:p>
         </p:txBody>
       </p:sp>
@@ -18849,6 +19425,54 @@
           <a:p>
             <a:pPr algn="ctr"/>
             <a:endParaRPr lang="en-US"/>
+          </a:p>
+        </p:txBody>
+      </p:sp>
+      <p:sp>
+        <p:nvSpPr>
+          <p:cNvPr id="3" name="AutoPageNum">
+            <a:extLst>
+              <a:ext uri="{FF2B5EF4-FFF2-40B4-BE49-F238E27FC236}">
+                <a16:creationId xmlns:a16="http://schemas.microsoft.com/office/drawing/2014/main" id="{F85CE76B-22FE-0B81-1793-3716CF5D5430}"/>
+              </a:ext>
+            </a:extLst>
+          </p:cNvPr>
+          <p:cNvSpPr txBox="1"/>
+          <p:nvPr/>
+        </p:nvSpPr>
+        <p:spPr>
+          <a:xfrm>
+            <a:off x="11633200" y="6451600"/>
+            <a:ext cx="508000" cy="304800"/>
+          </a:xfrm>
+          <a:prstGeom prst="rect">
+            <a:avLst/>
+          </a:prstGeom>
+          <a:noFill/>
+        </p:spPr>
+        <p:txBody>
+          <a:bodyPr vert="horz" wrap="square" lIns="0" tIns="0" rIns="0" bIns="0" rtlCol="0">
+            <a:noAutofit/>
+          </a:bodyPr>
+          <a:lstStyle/>
+          <a:p>
+            <a:pPr algn="ctr"/>
+            <a:fld id="{85DC9EE8-524A-4465-AB9F-58D1BAAC69F7}" type="slidenum">
+              <a:rPr lang="en-US" sz="1400" smtClean="0">
+                <a:solidFill>
+                  <a:srgbClr val="FFFFFF"/>
+                </a:solidFill>
+                <a:latin typeface="Arial" panose="020B0604020202020204" pitchFamily="34" charset="0"/>
+              </a:rPr>
+              <a:pPr algn="ctr"/>
+              <a:t>20</a:t>
+            </a:fld>
+            <a:endParaRPr lang="en-US" sz="1400">
+              <a:solidFill>
+                <a:srgbClr val="FFFFFF"/>
+              </a:solidFill>
+              <a:latin typeface="Arial" panose="020B0604020202020204" pitchFamily="34" charset="0"/>
+            </a:endParaRPr>
           </a:p>
         </p:txBody>
       </p:sp>
@@ -19829,6 +20453,54 @@
           </a:p>
         </p:txBody>
       </p:sp>
+      <p:sp>
+        <p:nvSpPr>
+          <p:cNvPr id="3" name="AutoPageNum">
+            <a:extLst>
+              <a:ext uri="{FF2B5EF4-FFF2-40B4-BE49-F238E27FC236}">
+                <a16:creationId xmlns:a16="http://schemas.microsoft.com/office/drawing/2014/main" id="{28F0E076-64C2-4451-685C-D5994D852A0B}"/>
+              </a:ext>
+            </a:extLst>
+          </p:cNvPr>
+          <p:cNvSpPr txBox="1"/>
+          <p:nvPr/>
+        </p:nvSpPr>
+        <p:spPr>
+          <a:xfrm>
+            <a:off x="11633200" y="6451600"/>
+            <a:ext cx="508000" cy="304800"/>
+          </a:xfrm>
+          <a:prstGeom prst="rect">
+            <a:avLst/>
+          </a:prstGeom>
+          <a:noFill/>
+        </p:spPr>
+        <p:txBody>
+          <a:bodyPr vert="horz" wrap="square" lIns="0" tIns="0" rIns="0" bIns="0" rtlCol="0">
+            <a:noAutofit/>
+          </a:bodyPr>
+          <a:lstStyle/>
+          <a:p>
+            <a:pPr algn="ctr"/>
+            <a:fld id="{0DFC2B71-D4A8-4279-8099-AA8B000C7CEE}" type="slidenum">
+              <a:rPr lang="en-US" sz="1400" smtClean="0">
+                <a:solidFill>
+                  <a:srgbClr val="000000"/>
+                </a:solidFill>
+                <a:latin typeface="Arial" panose="020B0604020202020204" pitchFamily="34" charset="0"/>
+              </a:rPr>
+              <a:pPr algn="ctr"/>
+              <a:t>21</a:t>
+            </a:fld>
+            <a:endParaRPr lang="en-US" sz="1400">
+              <a:solidFill>
+                <a:srgbClr val="000000"/>
+              </a:solidFill>
+              <a:latin typeface="Arial" panose="020B0604020202020204" pitchFamily="34" charset="0"/>
+            </a:endParaRPr>
+          </a:p>
+        </p:txBody>
+      </p:sp>
     </p:spTree>
     <p:extLst>
       <p:ext uri="{BB962C8B-B14F-4D97-AF65-F5344CB8AC3E}">
@@ -23720,6 +24392,54 @@
           </a:xfrm>
         </p:grpSpPr>
       </p:grpSp>
+      <p:sp>
+        <p:nvSpPr>
+          <p:cNvPr id="6" name="AutoPageNum">
+            <a:extLst>
+              <a:ext uri="{FF2B5EF4-FFF2-40B4-BE49-F238E27FC236}">
+                <a16:creationId xmlns:a16="http://schemas.microsoft.com/office/drawing/2014/main" id="{28182CEB-F7BE-970F-C642-5E20CF4EBAB5}"/>
+              </a:ext>
+            </a:extLst>
+          </p:cNvPr>
+          <p:cNvSpPr txBox="1"/>
+          <p:nvPr/>
+        </p:nvSpPr>
+        <p:spPr>
+          <a:xfrm>
+            <a:off x="11633200" y="6451600"/>
+            <a:ext cx="508000" cy="304800"/>
+          </a:xfrm>
+          <a:prstGeom prst="rect">
+            <a:avLst/>
+          </a:prstGeom>
+          <a:noFill/>
+        </p:spPr>
+        <p:txBody>
+          <a:bodyPr vert="horz" wrap="square" lIns="0" tIns="0" rIns="0" bIns="0" rtlCol="0">
+            <a:noAutofit/>
+          </a:bodyPr>
+          <a:lstStyle/>
+          <a:p>
+            <a:pPr algn="ctr"/>
+            <a:fld id="{4B65857A-4EE8-4826-885E-0B045A3EA135}" type="slidenum">
+              <a:rPr lang="en-US" sz="1400" smtClean="0">
+                <a:solidFill>
+                  <a:srgbClr val="FFFFFF"/>
+                </a:solidFill>
+                <a:latin typeface="Arial" panose="020B0604020202020204" pitchFamily="34" charset="0"/>
+              </a:rPr>
+              <a:pPr algn="ctr"/>
+              <a:t>22</a:t>
+            </a:fld>
+            <a:endParaRPr lang="en-US" sz="1400">
+              <a:solidFill>
+                <a:srgbClr val="FFFFFF"/>
+              </a:solidFill>
+              <a:latin typeface="Arial" panose="020B0604020202020204" pitchFamily="34" charset="0"/>
+            </a:endParaRPr>
+          </a:p>
+        </p:txBody>
+      </p:sp>
     </p:spTree>
     <p:extLst>
       <p:ext uri="{BB962C8B-B14F-4D97-AF65-F5344CB8AC3E}">
@@ -26247,6 +26967,54 @@
           </a:p>
         </p:txBody>
       </p:sp>
+      <p:sp>
+        <p:nvSpPr>
+          <p:cNvPr id="2" name="AutoPageNum">
+            <a:extLst>
+              <a:ext uri="{FF2B5EF4-FFF2-40B4-BE49-F238E27FC236}">
+                <a16:creationId xmlns:a16="http://schemas.microsoft.com/office/drawing/2014/main" id="{B52AD33E-486C-C93C-CBF3-2B8078281B61}"/>
+              </a:ext>
+            </a:extLst>
+          </p:cNvPr>
+          <p:cNvSpPr txBox="1"/>
+          <p:nvPr/>
+        </p:nvSpPr>
+        <p:spPr>
+          <a:xfrm>
+            <a:off x="11633200" y="6451600"/>
+            <a:ext cx="508000" cy="304800"/>
+          </a:xfrm>
+          <a:prstGeom prst="rect">
+            <a:avLst/>
+          </a:prstGeom>
+          <a:noFill/>
+        </p:spPr>
+        <p:txBody>
+          <a:bodyPr vert="horz" wrap="square" lIns="0" tIns="0" rIns="0" bIns="0" rtlCol="0">
+            <a:noAutofit/>
+          </a:bodyPr>
+          <a:lstStyle/>
+          <a:p>
+            <a:pPr algn="ctr"/>
+            <a:fld id="{D15DD420-B46E-428D-B301-577EF610F73A}" type="slidenum">
+              <a:rPr lang="en-US" sz="1400" smtClean="0">
+                <a:solidFill>
+                  <a:srgbClr val="000000"/>
+                </a:solidFill>
+                <a:latin typeface="Arial" panose="020B0604020202020204" pitchFamily="34" charset="0"/>
+              </a:rPr>
+              <a:pPr algn="ctr"/>
+              <a:t>23</a:t>
+            </a:fld>
+            <a:endParaRPr lang="en-US" sz="1400">
+              <a:solidFill>
+                <a:srgbClr val="000000"/>
+              </a:solidFill>
+              <a:latin typeface="Arial" panose="020B0604020202020204" pitchFamily="34" charset="0"/>
+            </a:endParaRPr>
+          </a:p>
+        </p:txBody>
+      </p:sp>
     </p:spTree>
   </p:cSld>
   <p:clrMapOvr>
@@ -27357,6 +28125,54 @@
           </a:p>
         </p:txBody>
       </p:sp>
+      <p:sp>
+        <p:nvSpPr>
+          <p:cNvPr id="3" name="AutoPageNum">
+            <a:extLst>
+              <a:ext uri="{FF2B5EF4-FFF2-40B4-BE49-F238E27FC236}">
+                <a16:creationId xmlns:a16="http://schemas.microsoft.com/office/drawing/2014/main" id="{FCD7D401-A2B7-CFAB-1245-AD96511D816E}"/>
+              </a:ext>
+            </a:extLst>
+          </p:cNvPr>
+          <p:cNvSpPr txBox="1"/>
+          <p:nvPr/>
+        </p:nvSpPr>
+        <p:spPr>
+          <a:xfrm>
+            <a:off x="11633200" y="6451600"/>
+            <a:ext cx="508000" cy="304800"/>
+          </a:xfrm>
+          <a:prstGeom prst="rect">
+            <a:avLst/>
+          </a:prstGeom>
+          <a:noFill/>
+        </p:spPr>
+        <p:txBody>
+          <a:bodyPr vert="horz" wrap="square" lIns="0" tIns="0" rIns="0" bIns="0" rtlCol="0">
+            <a:noAutofit/>
+          </a:bodyPr>
+          <a:lstStyle/>
+          <a:p>
+            <a:pPr algn="ctr"/>
+            <a:fld id="{7E5C6E68-B822-478D-BFB5-3325A127C6DF}" type="slidenum">
+              <a:rPr lang="en-US" sz="1400" smtClean="0">
+                <a:solidFill>
+                  <a:srgbClr val="FFFFFF"/>
+                </a:solidFill>
+                <a:latin typeface="Arial" panose="020B0604020202020204" pitchFamily="34" charset="0"/>
+              </a:rPr>
+              <a:pPr algn="ctr"/>
+              <a:t>24</a:t>
+            </a:fld>
+            <a:endParaRPr lang="en-US" sz="1400">
+              <a:solidFill>
+                <a:srgbClr val="FFFFFF"/>
+              </a:solidFill>
+              <a:latin typeface="Arial" panose="020B0604020202020204" pitchFamily="34" charset="0"/>
+            </a:endParaRPr>
+          </a:p>
+        </p:txBody>
+      </p:sp>
     </p:spTree>
     <p:extLst>
       <p:ext uri="{BB962C8B-B14F-4D97-AF65-F5344CB8AC3E}">
@@ -27425,6 +28241,54 @@
               <a:rPr lang="en-US" dirty="0"/>
               <a:t>Operating Cycle and Revenue Recognition Criteria</a:t>
             </a:r>
+          </a:p>
+        </p:txBody>
+      </p:sp>
+      <p:sp>
+        <p:nvSpPr>
+          <p:cNvPr id="3" name="AutoPageNum">
+            <a:extLst>
+              <a:ext uri="{FF2B5EF4-FFF2-40B4-BE49-F238E27FC236}">
+                <a16:creationId xmlns:a16="http://schemas.microsoft.com/office/drawing/2014/main" id="{B8C44202-F099-F4F8-313A-29BF91CACF57}"/>
+              </a:ext>
+            </a:extLst>
+          </p:cNvPr>
+          <p:cNvSpPr txBox="1"/>
+          <p:nvPr/>
+        </p:nvSpPr>
+        <p:spPr>
+          <a:xfrm>
+            <a:off x="11633200" y="6451600"/>
+            <a:ext cx="508000" cy="304800"/>
+          </a:xfrm>
+          <a:prstGeom prst="rect">
+            <a:avLst/>
+          </a:prstGeom>
+          <a:noFill/>
+        </p:spPr>
+        <p:txBody>
+          <a:bodyPr vert="horz" wrap="square" lIns="0" tIns="0" rIns="0" bIns="0" rtlCol="0">
+            <a:noAutofit/>
+          </a:bodyPr>
+          <a:lstStyle/>
+          <a:p>
+            <a:pPr algn="ctr"/>
+            <a:fld id="{0683CCB8-2F70-4240-821D-A7BF6EFDAE47}" type="slidenum">
+              <a:rPr lang="en-US" sz="1400" smtClean="0">
+                <a:solidFill>
+                  <a:srgbClr val="000000"/>
+                </a:solidFill>
+                <a:latin typeface="Arial" panose="020B0604020202020204" pitchFamily="34" charset="0"/>
+              </a:rPr>
+              <a:pPr algn="ctr"/>
+              <a:t>3</a:t>
+            </a:fld>
+            <a:endParaRPr lang="en-US" sz="1400">
+              <a:solidFill>
+                <a:srgbClr val="000000"/>
+              </a:solidFill>
+              <a:latin typeface="Arial" panose="020B0604020202020204" pitchFamily="34" charset="0"/>
+            </a:endParaRPr>
           </a:p>
         </p:txBody>
       </p:sp>
@@ -29335,6 +30199,54 @@
               <a:latin typeface="Arial" pitchFamily="34" charset="0"/>
               <a:ea typeface="Arial" pitchFamily="34" charset="-122"/>
               <a:cs typeface="Arial" pitchFamily="34" charset="-120"/>
+            </a:endParaRPr>
+          </a:p>
+        </p:txBody>
+      </p:sp>
+      <p:sp>
+        <p:nvSpPr>
+          <p:cNvPr id="5" name="AutoPageNum">
+            <a:extLst>
+              <a:ext uri="{FF2B5EF4-FFF2-40B4-BE49-F238E27FC236}">
+                <a16:creationId xmlns:a16="http://schemas.microsoft.com/office/drawing/2014/main" id="{B4FBF3A7-F12E-7B58-BDAC-9F136ABB0A23}"/>
+              </a:ext>
+            </a:extLst>
+          </p:cNvPr>
+          <p:cNvSpPr txBox="1"/>
+          <p:nvPr/>
+        </p:nvSpPr>
+        <p:spPr>
+          <a:xfrm>
+            <a:off x="11633200" y="6451600"/>
+            <a:ext cx="508000" cy="304800"/>
+          </a:xfrm>
+          <a:prstGeom prst="rect">
+            <a:avLst/>
+          </a:prstGeom>
+          <a:noFill/>
+        </p:spPr>
+        <p:txBody>
+          <a:bodyPr vert="horz" wrap="square" lIns="0" tIns="0" rIns="0" bIns="0" rtlCol="0">
+            <a:noAutofit/>
+          </a:bodyPr>
+          <a:lstStyle/>
+          <a:p>
+            <a:pPr algn="ctr"/>
+            <a:fld id="{E1E56761-8325-418B-BBB1-01754BA7141F}" type="slidenum">
+              <a:rPr lang="en-US" sz="1400" smtClean="0">
+                <a:solidFill>
+                  <a:srgbClr val="FFFFFF"/>
+                </a:solidFill>
+                <a:latin typeface="Arial" panose="020B0604020202020204" pitchFamily="34" charset="0"/>
+              </a:rPr>
+              <a:pPr algn="ctr"/>
+              <a:t>4</a:t>
+            </a:fld>
+            <a:endParaRPr lang="en-US" sz="1400">
+              <a:solidFill>
+                <a:srgbClr val="FFFFFF"/>
+              </a:solidFill>
+              <a:latin typeface="Arial" panose="020B0604020202020204" pitchFamily="34" charset="0"/>
             </a:endParaRPr>
           </a:p>
         </p:txBody>
@@ -31552,6 +32464,54 @@
           </a:p>
         </p:txBody>
       </p:sp>
+      <p:sp>
+        <p:nvSpPr>
+          <p:cNvPr id="5" name="AutoPageNum">
+            <a:extLst>
+              <a:ext uri="{FF2B5EF4-FFF2-40B4-BE49-F238E27FC236}">
+                <a16:creationId xmlns:a16="http://schemas.microsoft.com/office/drawing/2014/main" id="{D205863E-A082-B686-91B0-44E587F73896}"/>
+              </a:ext>
+            </a:extLst>
+          </p:cNvPr>
+          <p:cNvSpPr txBox="1"/>
+          <p:nvPr/>
+        </p:nvSpPr>
+        <p:spPr>
+          <a:xfrm>
+            <a:off x="11633200" y="6451600"/>
+            <a:ext cx="508000" cy="304800"/>
+          </a:xfrm>
+          <a:prstGeom prst="rect">
+            <a:avLst/>
+          </a:prstGeom>
+          <a:noFill/>
+        </p:spPr>
+        <p:txBody>
+          <a:bodyPr vert="horz" wrap="square" lIns="0" tIns="0" rIns="0" bIns="0" rtlCol="0">
+            <a:noAutofit/>
+          </a:bodyPr>
+          <a:lstStyle/>
+          <a:p>
+            <a:pPr algn="ctr"/>
+            <a:fld id="{9DEBC556-0CBF-44D1-A35B-2C0414B94E65}" type="slidenum">
+              <a:rPr lang="en-US" sz="1400" smtClean="0">
+                <a:solidFill>
+                  <a:srgbClr val="FFFFFF"/>
+                </a:solidFill>
+                <a:latin typeface="Arial" panose="020B0604020202020204" pitchFamily="34" charset="0"/>
+              </a:rPr>
+              <a:pPr algn="ctr"/>
+              <a:t>5</a:t>
+            </a:fld>
+            <a:endParaRPr lang="en-US" sz="1400">
+              <a:solidFill>
+                <a:srgbClr val="FFFFFF"/>
+              </a:solidFill>
+              <a:latin typeface="Arial" panose="020B0604020202020204" pitchFamily="34" charset="0"/>
+            </a:endParaRPr>
+          </a:p>
+        </p:txBody>
+      </p:sp>
     </p:spTree>
     <p:extLst>
       <p:ext uri="{BB962C8B-B14F-4D97-AF65-F5344CB8AC3E}">
@@ -34470,6 +35430,54 @@
           </p:sp>
         </p:grpSp>
       </p:grpSp>
+      <p:sp>
+        <p:nvSpPr>
+          <p:cNvPr id="7" name="AutoPageNum">
+            <a:extLst>
+              <a:ext uri="{FF2B5EF4-FFF2-40B4-BE49-F238E27FC236}">
+                <a16:creationId xmlns:a16="http://schemas.microsoft.com/office/drawing/2014/main" id="{6AE6D63F-D3F0-4924-6792-DC81DD6D83E4}"/>
+              </a:ext>
+            </a:extLst>
+          </p:cNvPr>
+          <p:cNvSpPr txBox="1"/>
+          <p:nvPr/>
+        </p:nvSpPr>
+        <p:spPr>
+          <a:xfrm>
+            <a:off x="11633200" y="6451600"/>
+            <a:ext cx="508000" cy="304800"/>
+          </a:xfrm>
+          <a:prstGeom prst="rect">
+            <a:avLst/>
+          </a:prstGeom>
+          <a:noFill/>
+        </p:spPr>
+        <p:txBody>
+          <a:bodyPr vert="horz" wrap="square" lIns="0" tIns="0" rIns="0" bIns="0" rtlCol="0">
+            <a:noAutofit/>
+          </a:bodyPr>
+          <a:lstStyle/>
+          <a:p>
+            <a:pPr algn="ctr"/>
+            <a:fld id="{AB91F89F-9AFD-455E-BF9B-D428814AC99F}" type="slidenum">
+              <a:rPr lang="en-US" sz="1400" smtClean="0">
+                <a:solidFill>
+                  <a:srgbClr val="FFFFFF"/>
+                </a:solidFill>
+                <a:latin typeface="Arial" panose="020B0604020202020204" pitchFamily="34" charset="0"/>
+              </a:rPr>
+              <a:pPr algn="ctr"/>
+              <a:t>6</a:t>
+            </a:fld>
+            <a:endParaRPr lang="en-US" sz="1400">
+              <a:solidFill>
+                <a:srgbClr val="FFFFFF"/>
+              </a:solidFill>
+              <a:latin typeface="Arial" panose="020B0604020202020204" pitchFamily="34" charset="0"/>
+            </a:endParaRPr>
+          </a:p>
+        </p:txBody>
+      </p:sp>
     </p:spTree>
     <p:extLst>
       <p:ext uri="{BB962C8B-B14F-4D97-AF65-F5344CB8AC3E}">
@@ -35463,6 +36471,54 @@
           </a:p>
         </p:txBody>
       </p:sp>
+      <p:sp>
+        <p:nvSpPr>
+          <p:cNvPr id="3" name="AutoPageNum">
+            <a:extLst>
+              <a:ext uri="{FF2B5EF4-FFF2-40B4-BE49-F238E27FC236}">
+                <a16:creationId xmlns:a16="http://schemas.microsoft.com/office/drawing/2014/main" id="{097FF583-C86C-0D63-B73C-F1034248D0D0}"/>
+              </a:ext>
+            </a:extLst>
+          </p:cNvPr>
+          <p:cNvSpPr txBox="1"/>
+          <p:nvPr/>
+        </p:nvSpPr>
+        <p:spPr>
+          <a:xfrm>
+            <a:off x="11633200" y="6451600"/>
+            <a:ext cx="508000" cy="304800"/>
+          </a:xfrm>
+          <a:prstGeom prst="rect">
+            <a:avLst/>
+          </a:prstGeom>
+          <a:noFill/>
+        </p:spPr>
+        <p:txBody>
+          <a:bodyPr vert="horz" wrap="square" lIns="0" tIns="0" rIns="0" bIns="0" rtlCol="0">
+            <a:noAutofit/>
+          </a:bodyPr>
+          <a:lstStyle/>
+          <a:p>
+            <a:pPr algn="ctr"/>
+            <a:fld id="{FD45022C-9E2B-440D-9AD3-02AB417E3C1F}" type="slidenum">
+              <a:rPr lang="en-US" sz="1400" smtClean="0">
+                <a:solidFill>
+                  <a:srgbClr val="000000"/>
+                </a:solidFill>
+                <a:latin typeface="Arial" panose="020B0604020202020204" pitchFamily="34" charset="0"/>
+              </a:rPr>
+              <a:pPr algn="ctr"/>
+              <a:t>7</a:t>
+            </a:fld>
+            <a:endParaRPr lang="en-US" sz="1400">
+              <a:solidFill>
+                <a:srgbClr val="000000"/>
+              </a:solidFill>
+              <a:latin typeface="Arial" panose="020B0604020202020204" pitchFamily="34" charset="0"/>
+            </a:endParaRPr>
+          </a:p>
+        </p:txBody>
+      </p:sp>
     </p:spTree>
     <p:extLst>
       <p:ext uri="{BB962C8B-B14F-4D97-AF65-F5344CB8AC3E}">
@@ -35938,6 +36994,54 @@
               </a:tabLst>
             </a:pPr>
             <a:endParaRPr lang="en-US" sz="2000" dirty="0"/>
+          </a:p>
+        </p:txBody>
+      </p:sp>
+      <p:sp>
+        <p:nvSpPr>
+          <p:cNvPr id="10" name="AutoPageNum">
+            <a:extLst>
+              <a:ext uri="{FF2B5EF4-FFF2-40B4-BE49-F238E27FC236}">
+                <a16:creationId xmlns:a16="http://schemas.microsoft.com/office/drawing/2014/main" id="{C50C1933-9672-BC21-A27E-FDA9390614CD}"/>
+              </a:ext>
+            </a:extLst>
+          </p:cNvPr>
+          <p:cNvSpPr txBox="1"/>
+          <p:nvPr/>
+        </p:nvSpPr>
+        <p:spPr>
+          <a:xfrm>
+            <a:off x="11633200" y="6451600"/>
+            <a:ext cx="508000" cy="304800"/>
+          </a:xfrm>
+          <a:prstGeom prst="rect">
+            <a:avLst/>
+          </a:prstGeom>
+          <a:noFill/>
+        </p:spPr>
+        <p:txBody>
+          <a:bodyPr vert="horz" wrap="square" lIns="0" tIns="0" rIns="0" bIns="0" rtlCol="0">
+            <a:noAutofit/>
+          </a:bodyPr>
+          <a:lstStyle/>
+          <a:p>
+            <a:pPr algn="ctr"/>
+            <a:fld id="{2EEB8DD6-F010-4307-AD74-A8329447655C}" type="slidenum">
+              <a:rPr lang="en-US" sz="1400" smtClean="0">
+                <a:solidFill>
+                  <a:srgbClr val="FFFFFF"/>
+                </a:solidFill>
+                <a:latin typeface="Arial" panose="020B0604020202020204" pitchFamily="34" charset="0"/>
+              </a:rPr>
+              <a:pPr algn="ctr"/>
+              <a:t>8</a:t>
+            </a:fld>
+            <a:endParaRPr lang="en-US" sz="1400">
+              <a:solidFill>
+                <a:srgbClr val="FFFFFF"/>
+              </a:solidFill>
+              <a:latin typeface="Arial" panose="020B0604020202020204" pitchFamily="34" charset="0"/>
+            </a:endParaRPr>
           </a:p>
         </p:txBody>
       </p:sp>
@@ -37341,6 +38445,54 @@
           </a:fontRef>
         </p:style>
       </p:cxnSp>
+      <p:sp>
+        <p:nvSpPr>
+          <p:cNvPr id="3" name="AutoPageNum">
+            <a:extLst>
+              <a:ext uri="{FF2B5EF4-FFF2-40B4-BE49-F238E27FC236}">
+                <a16:creationId xmlns:a16="http://schemas.microsoft.com/office/drawing/2014/main" id="{7B24521D-E171-7C66-44B4-D737102FE4B5}"/>
+              </a:ext>
+            </a:extLst>
+          </p:cNvPr>
+          <p:cNvSpPr txBox="1"/>
+          <p:nvPr/>
+        </p:nvSpPr>
+        <p:spPr>
+          <a:xfrm>
+            <a:off x="11633200" y="6451600"/>
+            <a:ext cx="508000" cy="304800"/>
+          </a:xfrm>
+          <a:prstGeom prst="rect">
+            <a:avLst/>
+          </a:prstGeom>
+          <a:noFill/>
+        </p:spPr>
+        <p:txBody>
+          <a:bodyPr vert="horz" wrap="square" lIns="0" tIns="0" rIns="0" bIns="0" rtlCol="0">
+            <a:noAutofit/>
+          </a:bodyPr>
+          <a:lstStyle/>
+          <a:p>
+            <a:pPr algn="ctr"/>
+            <a:fld id="{84B03ADE-DA49-46B7-B8EC-D9F097F850FD}" type="slidenum">
+              <a:rPr lang="en-US" sz="1400" smtClean="0">
+                <a:solidFill>
+                  <a:srgbClr val="FFFFFF"/>
+                </a:solidFill>
+                <a:latin typeface="Arial" panose="020B0604020202020204" pitchFamily="34" charset="0"/>
+              </a:rPr>
+              <a:pPr algn="ctr"/>
+              <a:t>9</a:t>
+            </a:fld>
+            <a:endParaRPr lang="en-US" sz="1400">
+              <a:solidFill>
+                <a:srgbClr val="FFFFFF"/>
+              </a:solidFill>
+              <a:latin typeface="Arial" panose="020B0604020202020204" pitchFamily="34" charset="0"/>
+            </a:endParaRPr>
+          </a:p>
+        </p:txBody>
+      </p:sp>
     </p:spTree>
     <p:extLst>
       <p:ext uri="{BB962C8B-B14F-4D97-AF65-F5344CB8AC3E}">

</xml_diff>